<commit_message>
phase6: render-drift verification harness + icon-as-circle emitter fix
- slidekit/verify: soffice+pdftoppm render pipeline and two pixel heuristics
  (ink-outside-computed-rects, ink-in-0.5in-margin) over ResolvedDeck geometry.
  Pillow-only, C-level mask ops; thresholds tuned so clean example decks pass.
- emit: icons now render as a contained colored circle (Phase 2 spec) instead of
  an unmeasured [name] text label that overflowed its slot in real renderers —
  the harness flagged this as ~1.7% stray ink on icon decks.
- CLI: 'slidekit verify' (CI-only) renders decks and reports JSON pass/fail.
- tests/test_verify: all example decks pass the heuristics; sensitivity test
  proves the harness flags artificially shrunk geometry. Skipped when render
  tools absent. Full suite 144 passed, 1 skipped.

Co-Authored-By: Claude Opus 4.8 <noreply@anthropic.com>
</commit_message>
<xml_diff>
--- a/examples/demo-5.pptx
+++ b/examples/demo-5.pptx
@@ -3950,14 +3950,58 @@
       </p:sp>
       <p:sp>
         <p:nvSpPr>
-          <p:cNvPr id="3" name="TextBox 2"/>
+          <p:cNvPr id="3" name="Oval 2"/>
+          <p:cNvSpPr/>
+          <p:nvPr/>
+        </p:nvSpPr>
+        <p:spPr>
+          <a:xfrm>
+            <a:off x="457200" y="1844040"/>
+            <a:ext cx="548640" cy="548640"/>
+          </a:xfrm>
+          <a:prstGeom prst="ellipse">
+            <a:avLst/>
+          </a:prstGeom>
+          <a:solidFill>
+            <a:srgbClr val="E84545"/>
+          </a:solidFill>
+          <a:ln>
+            <a:noFill/>
+          </a:ln>
+          <a:effectLst/>
+        </p:spPr>
+        <p:style>
+          <a:lnRef idx="1">
+            <a:schemeClr val="accent1"/>
+          </a:lnRef>
+          <a:fillRef idx="3">
+            <a:schemeClr val="accent1"/>
+          </a:fillRef>
+          <a:effectRef idx="2">
+            <a:schemeClr val="accent1"/>
+          </a:effectRef>
+          <a:fontRef idx="minor">
+            <a:schemeClr val="lt1"/>
+          </a:fontRef>
+        </p:style>
+        <p:txBody>
+          <a:bodyPr rtlCol="0" anchor="ctr"/>
+          <a:lstStyle/>
+          <a:p>
+            <a:pPr algn="ctr"/>
+          </a:p>
+        </p:txBody>
+      </p:sp>
+      <p:sp>
+        <p:nvSpPr>
+          <p:cNvPr id="4" name="TextBox 3"/>
           <p:cNvSpPr txBox="1"/>
           <p:nvPr/>
         </p:nvSpPr>
         <p:spPr>
           <a:xfrm>
-            <a:off x="457200" y="1844040"/>
-            <a:ext cx="548640" cy="548640"/>
+            <a:off x="1188720" y="1499616"/>
+            <a:ext cx="10546080" cy="518159"/>
           </a:xfrm>
           <a:prstGeom prst="rect">
             <a:avLst/>
@@ -3965,34 +4009,34 @@
           <a:noFill/>
         </p:spPr>
         <p:txBody>
-          <a:bodyPr wrap="none" lIns="0" rIns="0" tIns="0" bIns="0">
+          <a:bodyPr wrap="square">
             <a:noAutofit/>
           </a:bodyPr>
           <a:lstStyle/>
           <a:p>
-            <a:pPr algn="ctr"/>
-            <a:r>
-              <a:rPr sz="1600" b="1">
-                <a:solidFill>
-                  <a:srgbClr val="E84545"/>
+            <a:pPr algn="l"/>
+            <a:r>
+              <a:rPr sz="3400" b="1" i="0">
+                <a:solidFill>
+                  <a:srgbClr val="1A1A2E"/>
                 </a:solidFill>
                 <a:latin typeface="Arial"/>
               </a:rPr>
-              <a:t>[check]</a:t>
-            </a:r>
-          </a:p>
-        </p:txBody>
-      </p:sp>
-      <p:sp>
-        <p:nvSpPr>
-          <p:cNvPr id="4" name="TextBox 3"/>
+              <a:t>Deterministic</a:t>
+            </a:r>
+          </a:p>
+        </p:txBody>
+      </p:sp>
+      <p:sp>
+        <p:nvSpPr>
+          <p:cNvPr id="5" name="TextBox 4"/>
           <p:cNvSpPr txBox="1"/>
           <p:nvPr/>
         </p:nvSpPr>
         <p:spPr>
           <a:xfrm>
-            <a:off x="1188720" y="1499616"/>
-            <a:ext cx="10546080" cy="518159"/>
+            <a:off x="1188720" y="2292095"/>
+            <a:ext cx="10546080" cy="445009"/>
           </a:xfrm>
           <a:prstGeom prst="rect">
             <a:avLst/>
@@ -4007,27 +4051,71 @@
           <a:p>
             <a:pPr algn="l"/>
             <a:r>
-              <a:rPr sz="3400" b="1" i="0">
+              <a:rPr sz="3400" b="0" i="0">
                 <a:solidFill>
                   <a:srgbClr val="1A1A2E"/>
                 </a:solidFill>
                 <a:latin typeface="Arial"/>
               </a:rPr>
-              <a:t>Deterministic</a:t>
-            </a:r>
-          </a:p>
-        </p:txBody>
-      </p:sp>
-      <p:sp>
-        <p:nvSpPr>
-          <p:cNvPr id="5" name="TextBox 4"/>
+              <a:t>Same input always produces same output.</a:t>
+            </a:r>
+          </a:p>
+        </p:txBody>
+      </p:sp>
+      <p:sp>
+        <p:nvSpPr>
+          <p:cNvPr id="6" name="Oval 5"/>
+          <p:cNvSpPr/>
+          <p:nvPr/>
+        </p:nvSpPr>
+        <p:spPr>
+          <a:xfrm>
+            <a:off x="457200" y="3355848"/>
+            <a:ext cx="548640" cy="548640"/>
+          </a:xfrm>
+          <a:prstGeom prst="ellipse">
+            <a:avLst/>
+          </a:prstGeom>
+          <a:solidFill>
+            <a:srgbClr val="E84545"/>
+          </a:solidFill>
+          <a:ln>
+            <a:noFill/>
+          </a:ln>
+          <a:effectLst/>
+        </p:spPr>
+        <p:style>
+          <a:lnRef idx="1">
+            <a:schemeClr val="accent1"/>
+          </a:lnRef>
+          <a:fillRef idx="3">
+            <a:schemeClr val="accent1"/>
+          </a:fillRef>
+          <a:effectRef idx="2">
+            <a:schemeClr val="accent1"/>
+          </a:effectRef>
+          <a:fontRef idx="minor">
+            <a:schemeClr val="lt1"/>
+          </a:fontRef>
+        </p:style>
+        <p:txBody>
+          <a:bodyPr rtlCol="0" anchor="ctr"/>
+          <a:lstStyle/>
+          <a:p>
+            <a:pPr algn="ctr"/>
+          </a:p>
+        </p:txBody>
+      </p:sp>
+      <p:sp>
+        <p:nvSpPr>
+          <p:cNvPr id="7" name="TextBox 6"/>
           <p:cNvSpPr txBox="1"/>
           <p:nvPr/>
         </p:nvSpPr>
         <p:spPr>
           <a:xfrm>
-            <a:off x="1188720" y="2292095"/>
-            <a:ext cx="10546080" cy="445009"/>
+            <a:off x="1188720" y="3011424"/>
+            <a:ext cx="10546080" cy="518159"/>
           </a:xfrm>
           <a:prstGeom prst="rect">
             <a:avLst/>
@@ -4042,27 +4130,27 @@
           <a:p>
             <a:pPr algn="l"/>
             <a:r>
-              <a:rPr sz="3400" b="0" i="0">
+              <a:rPr sz="3400" b="1" i="0">
                 <a:solidFill>
                   <a:srgbClr val="1A1A2E"/>
                 </a:solidFill>
                 <a:latin typeface="Arial"/>
               </a:rPr>
-              <a:t>Same input always produces same output.</a:t>
-            </a:r>
-          </a:p>
-        </p:txBody>
-      </p:sp>
-      <p:sp>
-        <p:nvSpPr>
-          <p:cNvPr id="6" name="TextBox 5"/>
+              <a:t>No screenshots</a:t>
+            </a:r>
+          </a:p>
+        </p:txBody>
+      </p:sp>
+      <p:sp>
+        <p:nvSpPr>
+          <p:cNvPr id="8" name="TextBox 7"/>
           <p:cNvSpPr txBox="1"/>
           <p:nvPr/>
         </p:nvSpPr>
         <p:spPr>
           <a:xfrm>
-            <a:off x="457200" y="3355848"/>
-            <a:ext cx="548640" cy="548640"/>
+            <a:off x="1188720" y="3803903"/>
+            <a:ext cx="10546080" cy="445009"/>
           </a:xfrm>
           <a:prstGeom prst="rect">
             <a:avLst/>
@@ -4070,41 +4158,6 @@
           <a:noFill/>
         </p:spPr>
         <p:txBody>
-          <a:bodyPr wrap="none" lIns="0" rIns="0" tIns="0" bIns="0">
-            <a:noAutofit/>
-          </a:bodyPr>
-          <a:lstStyle/>
-          <a:p>
-            <a:pPr algn="ctr"/>
-            <a:r>
-              <a:rPr sz="1600" b="1">
-                <a:solidFill>
-                  <a:srgbClr val="E84545"/>
-                </a:solidFill>
-                <a:latin typeface="Arial"/>
-              </a:rPr>
-              <a:t>[lock]</a:t>
-            </a:r>
-          </a:p>
-        </p:txBody>
-      </p:sp>
-      <p:sp>
-        <p:nvSpPr>
-          <p:cNvPr id="7" name="TextBox 6"/>
-          <p:cNvSpPr txBox="1"/>
-          <p:nvPr/>
-        </p:nvSpPr>
-        <p:spPr>
-          <a:xfrm>
-            <a:off x="1188720" y="3011424"/>
-            <a:ext cx="10546080" cy="518159"/>
-          </a:xfrm>
-          <a:prstGeom prst="rect">
-            <a:avLst/>
-          </a:prstGeom>
-          <a:noFill/>
-        </p:spPr>
-        <p:txBody>
           <a:bodyPr wrap="square">
             <a:noAutofit/>
           </a:bodyPr>
@@ -4112,41 +4165,6 @@
           <a:p>
             <a:pPr algn="l"/>
             <a:r>
-              <a:rPr sz="3400" b="1" i="0">
-                <a:solidFill>
-                  <a:srgbClr val="1A1A2E"/>
-                </a:solidFill>
-                <a:latin typeface="Arial"/>
-              </a:rPr>
-              <a:t>No screenshots</a:t>
-            </a:r>
-          </a:p>
-        </p:txBody>
-      </p:sp>
-      <p:sp>
-        <p:nvSpPr>
-          <p:cNvPr id="8" name="TextBox 7"/>
-          <p:cNvSpPr txBox="1"/>
-          <p:nvPr/>
-        </p:nvSpPr>
-        <p:spPr>
-          <a:xfrm>
-            <a:off x="1188720" y="3803903"/>
-            <a:ext cx="10546080" cy="445009"/>
-          </a:xfrm>
-          <a:prstGeom prst="rect">
-            <a:avLst/>
-          </a:prstGeom>
-          <a:noFill/>
-        </p:spPr>
-        <p:txBody>
-          <a:bodyPr wrap="square">
-            <a:noAutofit/>
-          </a:bodyPr>
-          <a:lstStyle/>
-          <a:p>
-            <a:pPr algn="l"/>
-            <a:r>
               <a:rPr sz="3400" b="0" i="0">
                 <a:solidFill>
                   <a:srgbClr val="1A1A2E"/>
@@ -4160,8 +4178,8 @@
       </p:sp>
       <p:sp>
         <p:nvSpPr>
-          <p:cNvPr id="9" name="TextBox 8"/>
-          <p:cNvSpPr txBox="1"/>
+          <p:cNvPr id="9" name="Oval 8"/>
+          <p:cNvSpPr/>
           <p:nvPr/>
         </p:nvSpPr>
         <p:spPr>
@@ -4169,27 +4187,36 @@
             <a:off x="457200" y="4867656"/>
             <a:ext cx="548640" cy="548640"/>
           </a:xfrm>
-          <a:prstGeom prst="rect">
+          <a:prstGeom prst="ellipse">
             <a:avLst/>
           </a:prstGeom>
-          <a:noFill/>
-        </p:spPr>
-        <p:txBody>
-          <a:bodyPr wrap="none" lIns="0" rIns="0" tIns="0" bIns="0">
-            <a:noAutofit/>
-          </a:bodyPr>
+          <a:solidFill>
+            <a:srgbClr val="E84545"/>
+          </a:solidFill>
+          <a:ln>
+            <a:noFill/>
+          </a:ln>
+          <a:effectLst/>
+        </p:spPr>
+        <p:style>
+          <a:lnRef idx="1">
+            <a:schemeClr val="accent1"/>
+          </a:lnRef>
+          <a:fillRef idx="3">
+            <a:schemeClr val="accent1"/>
+          </a:fillRef>
+          <a:effectRef idx="2">
+            <a:schemeClr val="accent1"/>
+          </a:effectRef>
+          <a:fontRef idx="minor">
+            <a:schemeClr val="lt1"/>
+          </a:fontRef>
+        </p:style>
+        <p:txBody>
+          <a:bodyPr rtlCol="0" anchor="ctr"/>
           <a:lstStyle/>
           <a:p>
             <a:pPr algn="ctr"/>
-            <a:r>
-              <a:rPr sz="1600" b="1">
-                <a:solidFill>
-                  <a:srgbClr val="E84545"/>
-                </a:solidFill>
-                <a:latin typeface="Arial"/>
-              </a:rPr>
-              <a:t>[bolt]</a:t>
-            </a:r>
           </a:p>
         </p:txBody>
       </p:sp>

</xml_diff>